<commit_message>
Presentación T1 AndiBite 2.0 (22 diapositivas) y fichas de buyer persona actualizadas a los datos APEIM
Co-Authored-By: Claude Fable 5.1 <noreply@anthropic.com>
Claude-Session: https://claude.ai/code/session_01Kfbf7cfV7pXUcNjjyaPCzV
</commit_message>
<xml_diff>
--- a/assets/buyer-personas/fichas_buyer_persona_editable_canva.pptx
+++ b/assets/buyer-personas/fichas_buyer_persona_editable_canva.pptx
@@ -3388,7 +3388,7 @@
                 </a:solidFill>
                 <a:latin typeface="Nunito"/>
               </a:rPr>
-              <a:t>37 años · San Borja</a:t>
+              <a:t>38 años · San Borja</a:t>
             </a:r>
           </a:p>
         </p:txBody>
@@ -3703,7 +3703,7 @@
                 </a:solidFill>
                 <a:latin typeface="Nunito"/>
               </a:rPr>
-              <a:t>S/16,000 al mes aprox.</a:t>
+              <a:t>S/13,500 al mes aprox.</a:t>
             </a:r>
           </a:p>
         </p:txBody>
@@ -4558,7 +4558,7 @@
                 </a:solidFill>
                 <a:latin typeface="Nunito"/>
               </a:rPr>
-              <a:t>41 años · La Molina</a:t>
+              <a:t>42 años · La Molina</a:t>
             </a:r>
           </a:p>
         </p:txBody>
@@ -4873,7 +4873,7 @@
                 </a:solidFill>
                 <a:latin typeface="Nunito"/>
               </a:rPr>
-              <a:t>S/22,000 al mes aprox.</a:t>
+              <a:t>S/18,000 al mes aprox.</a:t>
             </a:r>
           </a:p>
         </p:txBody>

</xml_diff>